<commit_message>
feat(reports): possibilité d'ajouter la dernière note dans les rapports
</commit_message>
<xml_diff>
--- a/apps/backend/src/plans/reports/generate-plan-report-pptx/docs/template_bilan.pptx
+++ b/apps/backend/src/plans/reports/generate-plan-report-pptx/docs/template_bilan.pptx
@@ -24285,6 +24285,230 @@
           <a:chExt cx="0" cy="0"/>
         </a:xfrm>
       </p:grpSpPr>
+      <p:grpSp>
+        <p:nvGrpSpPr>
+          <p:cNvPr id="6" name="Groupe 5">
+            <a:extLst>
+              <a:ext uri="{FF2B5EF4-FFF2-40B4-BE49-F238E27FC236}">
+                <a16:creationId xmlns:a16="http://schemas.microsoft.com/office/drawing/2014/main" id="{BDF11EFC-AEFF-A244-EACD-CE2C6C66011D}"/>
+              </a:ext>
+            </a:extLst>
+          </p:cNvPr>
+          <p:cNvGrpSpPr/>
+          <p:nvPr/>
+        </p:nvGrpSpPr>
+        <p:grpSpPr>
+          <a:xfrm>
+            <a:off x="493775" y="2658949"/>
+            <a:ext cx="5652600" cy="2275721"/>
+            <a:chOff x="493775" y="2658949"/>
+            <a:chExt cx="5652600" cy="2275721"/>
+          </a:xfrm>
+        </p:grpSpPr>
+        <p:sp>
+          <p:nvSpPr>
+            <p:cNvPr id="340" name="Google Shape;340;p43"/>
+            <p:cNvSpPr/>
+            <p:nvPr/>
+          </p:nvSpPr>
+          <p:spPr>
+            <a:xfrm>
+              <a:off x="493775" y="2658949"/>
+              <a:ext cx="5652600" cy="2275721"/>
+            </a:xfrm>
+            <a:prstGeom prst="roundRect">
+              <a:avLst>
+                <a:gd name="adj" fmla="val 6187"/>
+              </a:avLst>
+            </a:prstGeom>
+            <a:solidFill>
+              <a:srgbClr val="FFFFFF"/>
+            </a:solidFill>
+            <a:ln w="10250" cap="flat" cmpd="sng">
+              <a:solidFill>
+                <a:srgbClr val="EEEEEE"/>
+              </a:solidFill>
+              <a:prstDash val="solid"/>
+              <a:round/>
+              <a:headEnd type="none" w="sm" len="sm"/>
+              <a:tailEnd type="none" w="sm" len="sm"/>
+            </a:ln>
+          </p:spPr>
+          <p:txBody>
+            <a:bodyPr spcFirstLastPara="1" wrap="square" lIns="98575" tIns="98575" rIns="98575" bIns="98575" anchor="ctr" anchorCtr="0">
+              <a:noAutofit/>
+            </a:bodyPr>
+            <a:lstStyle/>
+            <a:p>
+              <a:pPr marL="0" lvl="0" indent="0" algn="ctr" rtl="0">
+                <a:spcBef>
+                  <a:spcPts val="0"/>
+                </a:spcBef>
+                <a:spcAft>
+                  <a:spcPts val="0"/>
+                </a:spcAft>
+                <a:buNone/>
+              </a:pPr>
+              <a:endParaRPr sz="1509" dirty="0">
+                <a:latin typeface="Poppins"/>
+                <a:ea typeface="Poppins"/>
+                <a:cs typeface="Poppins"/>
+                <a:sym typeface="Poppins"/>
+              </a:endParaRPr>
+            </a:p>
+          </p:txBody>
+        </p:sp>
+        <p:sp>
+          <p:nvSpPr>
+            <p:cNvPr id="341" name="Google Shape;341;p43"/>
+            <p:cNvSpPr txBox="1"/>
+            <p:nvPr/>
+          </p:nvSpPr>
+          <p:spPr>
+            <a:xfrm>
+              <a:off x="1230576" y="2891550"/>
+              <a:ext cx="4751700" cy="171650"/>
+            </a:xfrm>
+            <a:prstGeom prst="rect">
+              <a:avLst/>
+            </a:prstGeom>
+            <a:noFill/>
+            <a:ln>
+              <a:noFill/>
+            </a:ln>
+          </p:spPr>
+          <p:txBody>
+            <a:bodyPr spcFirstLastPara="1" wrap="square" lIns="0" tIns="0" rIns="0" bIns="0" anchor="t" anchorCtr="0">
+              <a:spAutoFit/>
+            </a:bodyPr>
+            <a:lstStyle/>
+            <a:p>
+              <a:pPr marL="0" lvl="0" indent="0" algn="l" rtl="0">
+                <a:lnSpc>
+                  <a:spcPct val="115000"/>
+                </a:lnSpc>
+                <a:spcBef>
+                  <a:spcPts val="0"/>
+                </a:spcBef>
+                <a:spcAft>
+                  <a:spcPts val="0"/>
+                </a:spcAft>
+                <a:buNone/>
+              </a:pPr>
+              <a:r>
+                <a:rPr lang="fr" sz="970" b="1" dirty="0">
+                  <a:solidFill>
+                    <a:schemeClr val="dk1"/>
+                  </a:solidFill>
+                  <a:latin typeface="Poppins"/>
+                  <a:ea typeface="Poppins"/>
+                  <a:cs typeface="Poppins"/>
+                  <a:sym typeface="Poppins"/>
+                </a:rPr>
+                <a:t>{{FICHE_INFORMATIONS_TITLE}} : </a:t>
+              </a:r>
+              <a:endParaRPr sz="970" b="1" dirty="0">
+                <a:solidFill>
+                  <a:schemeClr val="dk1"/>
+                </a:solidFill>
+                <a:latin typeface="Poppins"/>
+                <a:ea typeface="Poppins"/>
+                <a:cs typeface="Poppins"/>
+                <a:sym typeface="Poppins"/>
+              </a:endParaRPr>
+            </a:p>
+          </p:txBody>
+        </p:sp>
+        <p:pic>
+          <p:nvPicPr>
+            <p:cNvPr id="342" name="Google Shape;342;p43" title="document.png"/>
+            <p:cNvPicPr preferRelativeResize="0"/>
+            <p:nvPr/>
+          </p:nvPicPr>
+          <p:blipFill>
+            <a:blip r:embed="rId3">
+              <a:alphaModFix/>
+            </a:blip>
+            <a:stretch>
+              <a:fillRect/>
+            </a:stretch>
+          </p:blipFill>
+          <p:spPr>
+            <a:xfrm>
+              <a:off x="668525" y="2891550"/>
+              <a:ext cx="431275" cy="431275"/>
+            </a:xfrm>
+            <a:prstGeom prst="rect">
+              <a:avLst/>
+            </a:prstGeom>
+            <a:noFill/>
+            <a:ln>
+              <a:noFill/>
+            </a:ln>
+          </p:spPr>
+        </p:pic>
+        <p:sp>
+          <p:nvSpPr>
+            <p:cNvPr id="2" name="txt_fiche_informations">
+              <a:extLst>
+                <a:ext uri="{FF2B5EF4-FFF2-40B4-BE49-F238E27FC236}">
+                  <a16:creationId xmlns:a16="http://schemas.microsoft.com/office/drawing/2014/main" id="{00ECE0A5-BF98-5AAF-8EE6-7CB801390936}"/>
+                </a:ext>
+              </a:extLst>
+            </p:cNvPr>
+            <p:cNvSpPr txBox="1"/>
+            <p:nvPr/>
+          </p:nvSpPr>
+          <p:spPr>
+            <a:xfrm>
+              <a:off x="1052616" y="3073683"/>
+              <a:ext cx="4751700" cy="1681229"/>
+            </a:xfrm>
+            <a:prstGeom prst="rect">
+              <a:avLst/>
+            </a:prstGeom>
+            <a:noFill/>
+            <a:ln>
+              <a:noFill/>
+            </a:ln>
+          </p:spPr>
+          <p:txBody>
+            <a:bodyPr spcFirstLastPara="1" wrap="square" lIns="0" tIns="0" rIns="0" bIns="0" anchor="t" anchorCtr="0">
+              <a:normAutofit/>
+            </a:bodyPr>
+            <a:lstStyle/>
+            <a:p>
+              <a:pPr marL="168246" lvl="0" algn="l" rtl="0">
+                <a:lnSpc>
+                  <a:spcPct val="115000"/>
+                </a:lnSpc>
+                <a:spcBef>
+                  <a:spcPts val="0"/>
+                </a:spcBef>
+                <a:spcAft>
+                  <a:spcPts val="0"/>
+                </a:spcAft>
+                <a:buClr>
+                  <a:schemeClr val="dk1"/>
+                </a:buClr>
+                <a:buSzPts val="950"/>
+              </a:pPr>
+              <a:r>
+                <a:rPr lang="fr-FR" sz="950" dirty="0">
+                  <a:solidFill>
+                    <a:schemeClr val="dk1"/>
+                  </a:solidFill>
+                  <a:latin typeface="Poppins Medium"/>
+                  <a:ea typeface="Poppins Medium"/>
+                  <a:cs typeface="Poppins Medium"/>
+                  <a:sym typeface="Poppins Medium"/>
+                </a:rPr>
+                <a:t>{{FICHE_INFORMATIONS}}</a:t>
+              </a:r>
+            </a:p>
+          </p:txBody>
+        </p:sp>
+      </p:grpSp>
       <p:pic>
         <p:nvPicPr>
           <p:cNvPr id="338" name="Google Shape;338;p43" title="insert_image.png"/>
@@ -24292,7 +24516,7 @@
           <p:nvPr/>
         </p:nvPicPr>
         <p:blipFill rotWithShape="1">
-          <a:blip r:embed="rId3">
+          <a:blip r:embed="rId4">
             <a:alphaModFix/>
           </a:blip>
           <a:srcRect l="258" r="268"/>
@@ -24574,7 +24798,7 @@
             <p:nvPr/>
           </p:nvPicPr>
           <p:blipFill>
-            <a:blip r:embed="rId4">
+            <a:blip r:embed="rId5">
               <a:alphaModFix/>
             </a:blip>
             <a:stretch>
@@ -24669,259 +24893,6 @@
           </a:p>
         </p:txBody>
       </p:sp>
-      <p:grpSp>
-        <p:nvGrpSpPr>
-          <p:cNvPr id="339" name="Google Shape;339;p43"/>
-          <p:cNvGrpSpPr/>
-          <p:nvPr/>
-        </p:nvGrpSpPr>
-        <p:grpSpPr>
-          <a:xfrm>
-            <a:off x="493775" y="2658950"/>
-            <a:ext cx="5652600" cy="1339800"/>
-            <a:chOff x="493775" y="2658950"/>
-            <a:chExt cx="5652600" cy="1339800"/>
-          </a:xfrm>
-        </p:grpSpPr>
-        <p:sp>
-          <p:nvSpPr>
-            <p:cNvPr id="340" name="Google Shape;340;p43"/>
-            <p:cNvSpPr/>
-            <p:nvPr/>
-          </p:nvSpPr>
-          <p:spPr>
-            <a:xfrm>
-              <a:off x="493775" y="2658950"/>
-              <a:ext cx="5652600" cy="1339800"/>
-            </a:xfrm>
-            <a:prstGeom prst="roundRect">
-              <a:avLst>
-                <a:gd name="adj" fmla="val 6187"/>
-              </a:avLst>
-            </a:prstGeom>
-            <a:solidFill>
-              <a:srgbClr val="FFFFFF"/>
-            </a:solidFill>
-            <a:ln w="10250" cap="flat" cmpd="sng">
-              <a:solidFill>
-                <a:srgbClr val="EEEEEE"/>
-              </a:solidFill>
-              <a:prstDash val="solid"/>
-              <a:round/>
-              <a:headEnd type="none" w="sm" len="sm"/>
-              <a:tailEnd type="none" w="sm" len="sm"/>
-            </a:ln>
-          </p:spPr>
-          <p:txBody>
-            <a:bodyPr spcFirstLastPara="1" wrap="square" lIns="98575" tIns="98575" rIns="98575" bIns="98575" anchor="ctr" anchorCtr="0">
-              <a:noAutofit/>
-            </a:bodyPr>
-            <a:lstStyle/>
-            <a:p>
-              <a:pPr marL="0" lvl="0" indent="0" algn="ctr" rtl="0">
-                <a:spcBef>
-                  <a:spcPts val="0"/>
-                </a:spcBef>
-                <a:spcAft>
-                  <a:spcPts val="0"/>
-                </a:spcAft>
-                <a:buNone/>
-              </a:pPr>
-              <a:endParaRPr sz="1509">
-                <a:latin typeface="Poppins"/>
-                <a:ea typeface="Poppins"/>
-                <a:cs typeface="Poppins"/>
-                <a:sym typeface="Poppins"/>
-              </a:endParaRPr>
-            </a:p>
-          </p:txBody>
-        </p:sp>
-        <p:sp>
-          <p:nvSpPr>
-            <p:cNvPr id="341" name="Google Shape;341;p43"/>
-            <p:cNvSpPr txBox="1"/>
-            <p:nvPr/>
-          </p:nvSpPr>
-          <p:spPr>
-            <a:xfrm>
-              <a:off x="1230576" y="2891550"/>
-              <a:ext cx="4751700" cy="676019"/>
-            </a:xfrm>
-            <a:prstGeom prst="rect">
-              <a:avLst/>
-            </a:prstGeom>
-            <a:noFill/>
-            <a:ln>
-              <a:noFill/>
-            </a:ln>
-          </p:spPr>
-          <p:txBody>
-            <a:bodyPr spcFirstLastPara="1" wrap="square" lIns="0" tIns="0" rIns="0" bIns="0" anchor="t" anchorCtr="0">
-              <a:spAutoFit/>
-            </a:bodyPr>
-            <a:lstStyle/>
-            <a:p>
-              <a:pPr marL="0" lvl="0" indent="0" algn="l" rtl="0">
-                <a:lnSpc>
-                  <a:spcPct val="115000"/>
-                </a:lnSpc>
-                <a:spcBef>
-                  <a:spcPts val="0"/>
-                </a:spcBef>
-                <a:spcAft>
-                  <a:spcPts val="0"/>
-                </a:spcAft>
-                <a:buNone/>
-              </a:pPr>
-              <a:r>
-                <a:rPr lang="fr" sz="970" b="1" dirty="0">
-                  <a:solidFill>
-                    <a:schemeClr val="dk1"/>
-                  </a:solidFill>
-                  <a:latin typeface="Poppins"/>
-                  <a:ea typeface="Poppins"/>
-                  <a:cs typeface="Poppins"/>
-                  <a:sym typeface="Poppins"/>
-                </a:rPr>
-                <a:t>Informations importantes :  </a:t>
-              </a:r>
-              <a:endParaRPr sz="970" b="1" dirty="0">
-                <a:solidFill>
-                  <a:schemeClr val="dk1"/>
-                </a:solidFill>
-                <a:latin typeface="Poppins"/>
-                <a:ea typeface="Poppins"/>
-                <a:cs typeface="Poppins"/>
-                <a:sym typeface="Poppins"/>
-              </a:endParaRPr>
-            </a:p>
-            <a:p>
-              <a:pPr marL="457200" lvl="0" indent="-288954" algn="l" rtl="0">
-                <a:lnSpc>
-                  <a:spcPct val="115000"/>
-                </a:lnSpc>
-                <a:spcBef>
-                  <a:spcPts val="0"/>
-                </a:spcBef>
-                <a:spcAft>
-                  <a:spcPts val="0"/>
-                </a:spcAft>
-                <a:buClr>
-                  <a:schemeClr val="dk1"/>
-                </a:buClr>
-                <a:buSzPts val="950"/>
-                <a:buFont typeface="Poppins Medium"/>
-                <a:buChar char="●"/>
-              </a:pPr>
-              <a:r>
-                <a:rPr lang="fr" sz="950" dirty="0">
-                  <a:solidFill>
-                    <a:schemeClr val="dk1"/>
-                  </a:solidFill>
-                  <a:latin typeface="Poppins Medium"/>
-                  <a:ea typeface="Poppins Medium"/>
-                  <a:cs typeface="Poppins Medium"/>
-                  <a:sym typeface="Poppins Medium"/>
-                </a:rPr>
-                <a:t>Remplissez ici les informations importantes concernant l'action</a:t>
-              </a:r>
-              <a:endParaRPr sz="950" dirty="0">
-                <a:solidFill>
-                  <a:schemeClr val="dk1"/>
-                </a:solidFill>
-                <a:latin typeface="Poppins Medium"/>
-                <a:ea typeface="Poppins Medium"/>
-                <a:cs typeface="Poppins Medium"/>
-                <a:sym typeface="Poppins Medium"/>
-              </a:endParaRPr>
-            </a:p>
-            <a:p>
-              <a:pPr marL="457200" lvl="0" indent="-288954" algn="l" rtl="0">
-                <a:lnSpc>
-                  <a:spcPct val="115000"/>
-                </a:lnSpc>
-                <a:spcBef>
-                  <a:spcPts val="0"/>
-                </a:spcBef>
-                <a:spcAft>
-                  <a:spcPts val="0"/>
-                </a:spcAft>
-                <a:buClr>
-                  <a:schemeClr val="dk1"/>
-                </a:buClr>
-                <a:buSzPts val="950"/>
-                <a:buFont typeface="Poppins Medium"/>
-                <a:buChar char="●"/>
-              </a:pPr>
-              <a:endParaRPr sz="950" dirty="0">
-                <a:solidFill>
-                  <a:schemeClr val="dk1"/>
-                </a:solidFill>
-                <a:latin typeface="Poppins Medium"/>
-                <a:ea typeface="Poppins Medium"/>
-                <a:cs typeface="Poppins Medium"/>
-                <a:sym typeface="Poppins Medium"/>
-              </a:endParaRPr>
-            </a:p>
-            <a:p>
-              <a:pPr marL="457200" lvl="0" indent="-288954" algn="l" rtl="0">
-                <a:lnSpc>
-                  <a:spcPct val="115000"/>
-                </a:lnSpc>
-                <a:spcBef>
-                  <a:spcPts val="0"/>
-                </a:spcBef>
-                <a:spcAft>
-                  <a:spcPts val="0"/>
-                </a:spcAft>
-                <a:buClr>
-                  <a:schemeClr val="dk1"/>
-                </a:buClr>
-                <a:buSzPts val="950"/>
-                <a:buFont typeface="Poppins Medium"/>
-                <a:buChar char="●"/>
-              </a:pPr>
-              <a:endParaRPr sz="950" dirty="0">
-                <a:solidFill>
-                  <a:schemeClr val="dk1"/>
-                </a:solidFill>
-                <a:latin typeface="Poppins Medium"/>
-                <a:ea typeface="Poppins Medium"/>
-                <a:cs typeface="Poppins Medium"/>
-                <a:sym typeface="Poppins Medium"/>
-              </a:endParaRPr>
-            </a:p>
-          </p:txBody>
-        </p:sp>
-        <p:pic>
-          <p:nvPicPr>
-            <p:cNvPr id="342" name="Google Shape;342;p43" title="document.png"/>
-            <p:cNvPicPr preferRelativeResize="0"/>
-            <p:nvPr/>
-          </p:nvPicPr>
-          <p:blipFill>
-            <a:blip r:embed="rId5">
-              <a:alphaModFix/>
-            </a:blip>
-            <a:stretch>
-              <a:fillRect/>
-            </a:stretch>
-          </p:blipFill>
-          <p:spPr>
-            <a:xfrm>
-              <a:off x="668525" y="2891550"/>
-              <a:ext cx="431275" cy="431275"/>
-            </a:xfrm>
-            <a:prstGeom prst="rect">
-              <a:avLst/>
-            </a:prstGeom>
-            <a:noFill/>
-            <a:ln>
-              <a:noFill/>
-            </a:ln>
-          </p:spPr>
-        </p:pic>
-      </p:grpSp>
       <p:grpSp>
         <p:nvGrpSpPr>
           <p:cNvPr id="343" name="grp_fiche_missing_info"/>

</xml_diff>